<commit_message>
@ Update slides with current results (new baselines, generalization, FedGT tie)
Slide 8: baseline panel now lists Bulyan, geo-median/RFA, FLTrust, FedGT. Slide 11:
swap in the 8-method sign-flip figure, rewrite bullets (RFA also laundered; ties
FedGT at ~50%/f=0.3; detection 3/3,6/6,9/9 with FP 0.0/0.7/0.3 vs FedGT 1.3/3.3/1.3;
EMNIST 85% + Edge 62% generalization). Slide 4: name FedGT as closest robustness
peer. Slide 12: four-dataset validation. Edited in place to preserve the deck DNA;
add experiments/update_slides.py.

Co-Authored-By: Claude Opus 4.8 <noreply@anthropic.com>
@
</commit_message>
<xml_diff>
--- a/paper/cbsafe_slides.pptx
+++ b/paper/cbsafe_slides.pptx
@@ -4029,25 +4029,7 @@
                 </a:solidFill>
                 <a:latin typeface="Segoe UI"/>
               </a:rPr>
-              <a:t>▪  </a:t>
-            </a:r>
-            <a:r>
-              <a:rPr sz="1550" b="1">
-                <a:solidFill>
-                  <a:srgbClr val="0B0B0B"/>
-                </a:solidFill>
-                <a:latin typeface="Segoe UI"/>
-              </a:rPr>
-              <a:t>Why rules fail: </a:t>
-            </a:r>
-            <a:r>
-              <a:rPr sz="1550">
-                <a:solidFill>
-                  <a:srgbClr val="26251F"/>
-                </a:solidFill>
-                <a:latin typeface="Segoe UI"/>
-              </a:rPr>
-              <a:t>averaging inside a cluster disguises the poison (the sum has a normal size, just the wrong direction), so trimmed mean and median fall to 10% (random guessing) at f ≥ 20%.</a:t>
+              <a:t>▪  Why rules fail: cluster averaging disguises the poison (normal size, wrong direction), so mean, trimmed mean, median and even the robust geometric median (RFA) fall to ~10% (random) at f ≥ 20%; Multi-Krum and Bulyan degrade but hold longer.</a:t>
             </a:r>
           </a:p>
           <a:p>
@@ -4066,25 +4048,7 @@
                 </a:solidFill>
                 <a:latin typeface="Segoe UI"/>
               </a:rPr>
-              <a:t>▪  </a:t>
-            </a:r>
-            <a:r>
-              <a:rPr sz="1550" b="1">
-                <a:solidFill>
-                  <a:srgbClr val="0B0B0B"/>
-                </a:solidFill>
-                <a:latin typeface="Segoe UI"/>
-              </a:rPr>
-              <a:t>CB-SAFE+ result: </a:t>
-            </a:r>
-            <a:r>
-              <a:rPr sz="1550">
-                <a:solidFill>
-                  <a:srgbClr val="26251F"/>
-                </a:solidFill>
-                <a:latin typeface="Segoe UI"/>
-              </a:rPr>
-              <a:t>catches 8 of 9 attackers at f = 30% with zero honest clients wrongly excluded, recovering 42.8% where every static rule reads 10–17%.</a:t>
+              <a:t>▪  Ties the state of the art: at f = 30% CB-SAFE+ holds ~50% accuracy, matching FedGT (TIFS 2025), while catching 3/3, 6/6, 9/9 attackers with far fewer false exclusions (0.0 / 0.7 / 0.3 vs FedGT 1.3 / 3.3 / 1.3).</a:t>
             </a:r>
           </a:p>
           <a:p>
@@ -4103,53 +4067,11 @@
                 </a:solidFill>
                 <a:latin typeface="Segoe UI"/>
               </a:rPr>
-              <a:t>▪  </a:t>
-            </a:r>
-            <a:r>
-              <a:rPr sz="1550" b="1">
-                <a:solidFill>
-                  <a:srgbClr val="0B0B0B"/>
-                </a:solidFill>
-                <a:latin typeface="Segoe UI"/>
-              </a:rPr>
-              <a:t>Honest limits: </a:t>
-            </a:r>
-            <a:r>
-              <a:rPr sz="1550">
-                <a:solidFill>
-                  <a:srgbClr val="26251F"/>
-                </a:solidFill>
-                <a:latin typeface="Segoe UI"/>
-              </a:rPr>
-              <a:t>stealthy backdoors evade all sum-level defenses (93–97% attack success for every rule); Multi-Krum stays stronger at f = 20%.</a:t>
-            </a:r>
-          </a:p>
-        </p:txBody>
-      </p:sp>
-      <p:pic>
-        <p:nvPicPr>
-          <p:cNvPr id="8" name="Picture 7" descr="fig_signflip_acc.png"/>
-          <p:cNvPicPr>
-            <a:picLocks noChangeAspect="1"/>
-          </p:cNvPicPr>
-          <p:nvPr/>
-        </p:nvPicPr>
-        <p:blipFill>
-          <a:blip r:embed="rId2"/>
-          <a:stretch>
-            <a:fillRect/>
-          </a:stretch>
-        </p:blipFill>
-        <p:spPr>
-          <a:xfrm>
-            <a:off x="6720840" y="1828800"/>
-            <a:ext cx="5074920" cy="3410491"/>
-          </a:xfrm>
-          <a:prstGeom prst="rect">
-            <a:avLst/>
-          </a:prstGeom>
-        </p:spPr>
-      </p:pic>
+              <a:t>▪  Generalizes across domains: the same collapse-and-recover pattern holds on EMNIST (85% at f = 30%) and tabular Edge-IIoTset (62%); stealthy backdoors remain an open limit for all sum-level defenses.</a:t>
+            </a:r>
+          </a:p>
+        </p:txBody>
+      </p:sp>
       <p:sp>
         <p:nvSpPr>
           <p:cNvPr id="9" name="TextBox 8"/>
@@ -4184,11 +4106,35 @@
                 </a:solidFill>
                 <a:latin typeface="Segoe UI"/>
               </a:rPr>
-              <a:t>Sign-flip attack: accuracy vs attacker fraction, per aggregation rule.</a:t>
-            </a:r>
-          </a:p>
-        </p:txBody>
-      </p:sp>
+              <a:t>Sign-flip attack on CIFAR-10: accuracy vs attacker fraction across eight rules; only CB-SAFE+ and FedGT stay near the clean baseline.</a:t>
+            </a:r>
+          </a:p>
+        </p:txBody>
+      </p:sp>
+      <p:pic>
+        <p:nvPicPr>
+          <p:cNvPr id="10" name="Picture 9" descr="fig_signflip_acc_slide.png"/>
+          <p:cNvPicPr>
+            <a:picLocks noChangeAspect="1"/>
+          </p:cNvPicPr>
+          <p:nvPr/>
+        </p:nvPicPr>
+        <p:blipFill>
+          <a:blip r:embed="rId3"/>
+          <a:stretch>
+            <a:fillRect/>
+          </a:stretch>
+        </p:blipFill>
+        <p:spPr>
+          <a:xfrm>
+            <a:off x="6720840" y="1828800"/>
+            <a:ext cx="5074920" cy="3410491"/>
+          </a:xfrm>
+          <a:prstGeom prst="rect">
+            <a:avLst/>
+          </a:prstGeom>
+        </p:spPr>
+      </p:pic>
     </p:spTree>
   </p:cSld>
   <p:clrMapOvr>
@@ -4451,25 +4397,7 @@
                 </a:solidFill>
                 <a:latin typeface="Segoe UI"/>
               </a:rPr>
-              <a:t>▪  </a:t>
-            </a:r>
-            <a:r>
-              <a:rPr sz="1700" b="1">
-                <a:solidFill>
-                  <a:srgbClr val="0B0B0B"/>
-                </a:solidFill>
-                <a:latin typeface="Segoe UI"/>
-              </a:rPr>
-              <a:t>Diversity delivered: </a:t>
-            </a:r>
-            <a:r>
-              <a:rPr sz="1700">
-                <a:solidFill>
-                  <a:srgbClr val="26251F"/>
-                </a:solidFill>
-                <a:latin typeface="Segoe UI"/>
-              </a:rPr>
-              <a:t>the first code-based post-quantum secure aggregation for FL, at a one-time cost under 0.03% of traffic.</a:t>
+              <a:t>▪  Diversity delivered: the first code-based post-quantum secure aggregation for FL, at a one-time cost under 0.03% of traffic.</a:t>
             </a:r>
           </a:p>
           <a:p>
@@ -4488,25 +4416,7 @@
                 </a:solidFill>
                 <a:latin typeface="Segoe UI"/>
               </a:rPr>
-              <a:t>▪  </a:t>
-            </a:r>
-            <a:r>
-              <a:rPr sz="1700" b="1">
-                <a:solidFill>
-                  <a:srgbClr val="0B0B0B"/>
-                </a:solidFill>
-                <a:latin typeface="Segoe UI"/>
-              </a:rPr>
-              <a:t>New understanding: </a:t>
-            </a:r>
-            <a:r>
-              <a:rPr sz="1700">
-                <a:solidFill>
-                  <a:srgbClr val="26251F"/>
-                </a:solidFill>
-                <a:latin typeface="Segoe UI"/>
-              </a:rPr>
-              <a:t>secure aggregation launders poisoning; defenses must use signals that survive summation, accumulated over rounds.</a:t>
+              <a:t>▪  New understanding: secure aggregation launders poisoning; defenses must use signals that survive summation, accumulated over rounds.</a:t>
             </a:r>
           </a:p>
           <a:p>
@@ -4525,25 +4435,7 @@
                 </a:solidFill>
                 <a:latin typeface="Segoe UI"/>
               </a:rPr>
-              <a:t>▪  </a:t>
-            </a:r>
-            <a:r>
-              <a:rPr sz="1700" b="1">
-                <a:solidFill>
-                  <a:srgbClr val="0B0B0B"/>
-                </a:solidFill>
-                <a:latin typeface="Segoe UI"/>
-              </a:rPr>
-              <a:t>New defense: </a:t>
-            </a:r>
-            <a:r>
-              <a:rPr sz="1700">
-                <a:solidFill>
-                  <a:srgbClr val="26251F"/>
-                </a:solidFill>
-                <a:latin typeface="Segoe UI"/>
-              </a:rPr>
-              <a:t>CB-SAFE+ identifies individual attackers from group observations only, with zero extra privacy leakage.</a:t>
+              <a:t>▪  New defense: CB-SAFE+ identifies individual attackers from group observations only, tying FedGT at ~4x lower cost with zero extra privacy leakage.</a:t>
             </a:r>
           </a:p>
           <a:p>
@@ -4562,25 +4454,7 @@
                 </a:solidFill>
                 <a:latin typeface="Segoe UI"/>
               </a:rPr>
-              <a:t>▪  </a:t>
-            </a:r>
-            <a:r>
-              <a:rPr sz="1700" b="1">
-                <a:solidFill>
-                  <a:srgbClr val="0B0B0B"/>
-                </a:solidFill>
-                <a:latin typeface="Segoe UI"/>
-              </a:rPr>
-              <a:t>Open problems: </a:t>
-            </a:r>
-            <a:r>
-              <a:rPr sz="1700">
-                <a:solidFill>
-                  <a:srgbClr val="26251F"/>
-                </a:solidFill>
-                <a:latin typeface="Segoe UI"/>
-              </a:rPr>
-              <a:t>stealthy backdoors, actively malicious servers, adaptive attackers.</a:t>
+              <a:t>▪  Open problems: stealthy backdoors, actively malicious servers, adaptive attackers.</a:t>
             </a:r>
           </a:p>
           <a:p>
@@ -4599,25 +4473,7 @@
                 </a:solidFill>
                 <a:latin typeface="Segoe UI"/>
               </a:rPr>
-              <a:t>▪  </a:t>
-            </a:r>
-            <a:r>
-              <a:rPr sz="1700" b="1">
-                <a:solidFill>
-                  <a:srgbClr val="0B0B0B"/>
-                </a:solidFill>
-                <a:latin typeface="Segoe UI"/>
-              </a:rPr>
-              <a:t>In progress: </a:t>
-            </a:r>
-            <a:r>
-              <a:rPr sz="1700">
-                <a:solidFill>
-                  <a:srgbClr val="26251F"/>
-                </a:solidFill>
-                <a:latin typeface="Segoe UI"/>
-              </a:rPr>
-              <a:t>multi-seed statistics, a second dataset, 100-client scale; implementation released open-source.</a:t>
+              <a:t>▪  Validated across four datasets (CIFAR-10, FashionMNIST, EMNIST, Edge-IIoTset); 100-client scale in progress; implementation released open-source.</a:t>
             </a:r>
           </a:p>
         </p:txBody>
@@ -6635,7 +6491,7 @@
                 </a:solidFill>
                 <a:latin typeface="Segoe UI"/>
               </a:rPr>
-              <a:t>CB-SAFE targets exactly these gaps. (2026 preprints confirm the gap is live: lattice+reputation and quantum-hardware approaches, but none is code-based.)</a:t>
+              <a:t>CB-SAFE targets exactly these gaps. The closest robustness peer, FedGT (TIFS 2025), also tests group sums but is not post-quantum; CB-SAFE matches its detection at lower cost and adds code-based confidentiality.</a:t>
             </a:r>
           </a:p>
         </p:txBody>
@@ -9734,7 +9590,7 @@
                 </a:solidFill>
                 <a:latin typeface="Segoe UI"/>
               </a:rPr>
-              <a:t>Baselines: plain FedAvg, lattice (ML-KEM) variant, and four standard robust rules (mean, trimmed mean, median, Multi-Krum), all at matched NIST security levels.</a:t>
+              <a:t>Baselines: plain FedAvg and the lattice (ML-KEM) variant, plus eight robust rules at matched NIST levels: mean, trimmed mean, median, Multi-Krum, Bulyan, geometric-median (RFA), FLTrust, and the SOTA group-testing method FedGT (TIFS 2025).</a:t>
             </a:r>
           </a:p>
         </p:txBody>

</xml_diff>

<commit_message>
@ Slides: remove left blue accent bar (all 12); add laundering illustration
Per user request: delete the left-edge blue accent bar from every slide, and add
a laundering-geometry illustration (standalone TikZ render) to slide 7 (CB-SAFE+),
where the "key insight" bullet describes exactly that effect. Shrink the bullet box
to free the right side; place the figure top-right clear of the step row.

Co-Authored-By: Claude Opus 4.8 <noreply@anthropic.com>
@
</commit_message>
<xml_diff>
--- a/paper/cbsafe_slides.pptx
+++ b/paper/cbsafe_slides.pptx
@@ -3109,49 +3109,6 @@
       <p:grpSpPr/>
       <p:sp>
         <p:nvSpPr>
-          <p:cNvPr id="2" name="Rectangle 1"/>
-          <p:cNvSpPr/>
-          <p:nvPr/>
-        </p:nvSpPr>
-        <p:spPr>
-          <a:xfrm>
-            <a:off x="0" y="0"/>
-            <a:ext cx="82296" cy="6858000"/>
-          </a:xfrm>
-          <a:prstGeom prst="rect">
-            <a:avLst/>
-          </a:prstGeom>
-          <a:solidFill>
-            <a:srgbClr val="2A78D6"/>
-          </a:solidFill>
-          <a:ln>
-            <a:noFill/>
-          </a:ln>
-        </p:spPr>
-        <p:style>
-          <a:lnRef idx="1">
-            <a:schemeClr val="accent1"/>
-          </a:lnRef>
-          <a:fillRef idx="3">
-            <a:schemeClr val="accent1"/>
-          </a:fillRef>
-          <a:effectRef idx="2">
-            <a:schemeClr val="accent1"/>
-          </a:effectRef>
-          <a:fontRef idx="minor">
-            <a:schemeClr val="lt1"/>
-          </a:fontRef>
-        </p:style>
-        <p:txBody>
-          <a:bodyPr rtlCol="0" anchor="ctr"/>
-          <a:lstStyle/>
-          <a:p>
-            <a:pPr algn="ctr"/>
-          </a:p>
-        </p:txBody>
-      </p:sp>
-      <p:sp>
-        <p:nvSpPr>
           <p:cNvPr id="3" name="TextBox 2"/>
           <p:cNvSpPr txBox="1"/>
           <p:nvPr/>
@@ -3373,49 +3330,6 @@
       <p:grpSpPr/>
       <p:sp>
         <p:nvSpPr>
-          <p:cNvPr id="2" name="Rectangle 1"/>
-          <p:cNvSpPr/>
-          <p:nvPr/>
-        </p:nvSpPr>
-        <p:spPr>
-          <a:xfrm>
-            <a:off x="0" y="0"/>
-            <a:ext cx="82296" cy="6858000"/>
-          </a:xfrm>
-          <a:prstGeom prst="rect">
-            <a:avLst/>
-          </a:prstGeom>
-          <a:solidFill>
-            <a:srgbClr val="2A78D6"/>
-          </a:solidFill>
-          <a:ln>
-            <a:noFill/>
-          </a:ln>
-        </p:spPr>
-        <p:style>
-          <a:lnRef idx="1">
-            <a:schemeClr val="accent1"/>
-          </a:lnRef>
-          <a:fillRef idx="3">
-            <a:schemeClr val="accent1"/>
-          </a:fillRef>
-          <a:effectRef idx="2">
-            <a:schemeClr val="accent1"/>
-          </a:effectRef>
-          <a:fontRef idx="minor">
-            <a:schemeClr val="lt1"/>
-          </a:fontRef>
-        </p:style>
-        <p:txBody>
-          <a:bodyPr rtlCol="0" anchor="ctr"/>
-          <a:lstStyle/>
-          <a:p>
-            <a:pPr algn="ctr"/>
-          </a:p>
-        </p:txBody>
-      </p:sp>
-      <p:sp>
-        <p:nvSpPr>
           <p:cNvPr id="3" name="TextBox 2"/>
           <p:cNvSpPr txBox="1"/>
           <p:nvPr/>
@@ -3793,49 +3707,6 @@
         <p:nvPr/>
       </p:nvGrpSpPr>
       <p:grpSpPr/>
-      <p:sp>
-        <p:nvSpPr>
-          <p:cNvPr id="2" name="Rectangle 1"/>
-          <p:cNvSpPr/>
-          <p:nvPr/>
-        </p:nvSpPr>
-        <p:spPr>
-          <a:xfrm>
-            <a:off x="0" y="0"/>
-            <a:ext cx="82296" cy="6858000"/>
-          </a:xfrm>
-          <a:prstGeom prst="rect">
-            <a:avLst/>
-          </a:prstGeom>
-          <a:solidFill>
-            <a:srgbClr val="2A78D6"/>
-          </a:solidFill>
-          <a:ln>
-            <a:noFill/>
-          </a:ln>
-        </p:spPr>
-        <p:style>
-          <a:lnRef idx="1">
-            <a:schemeClr val="accent1"/>
-          </a:lnRef>
-          <a:fillRef idx="3">
-            <a:schemeClr val="accent1"/>
-          </a:fillRef>
-          <a:effectRef idx="2">
-            <a:schemeClr val="accent1"/>
-          </a:effectRef>
-          <a:fontRef idx="minor">
-            <a:schemeClr val="lt1"/>
-          </a:fontRef>
-        </p:style>
-        <p:txBody>
-          <a:bodyPr rtlCol="0" anchor="ctr"/>
-          <a:lstStyle/>
-          <a:p>
-            <a:pPr algn="ctr"/>
-          </a:p>
-        </p:txBody>
-      </p:sp>
       <p:sp>
         <p:nvSpPr>
           <p:cNvPr id="3" name="TextBox 2"/>
@@ -4163,49 +4034,6 @@
       <p:grpSpPr/>
       <p:sp>
         <p:nvSpPr>
-          <p:cNvPr id="2" name="Rectangle 1"/>
-          <p:cNvSpPr/>
-          <p:nvPr/>
-        </p:nvSpPr>
-        <p:spPr>
-          <a:xfrm>
-            <a:off x="0" y="0"/>
-            <a:ext cx="82296" cy="6858000"/>
-          </a:xfrm>
-          <a:prstGeom prst="rect">
-            <a:avLst/>
-          </a:prstGeom>
-          <a:solidFill>
-            <a:srgbClr val="2A78D6"/>
-          </a:solidFill>
-          <a:ln>
-            <a:noFill/>
-          </a:ln>
-        </p:spPr>
-        <p:style>
-          <a:lnRef idx="1">
-            <a:schemeClr val="accent1"/>
-          </a:lnRef>
-          <a:fillRef idx="3">
-            <a:schemeClr val="accent1"/>
-          </a:fillRef>
-          <a:effectRef idx="2">
-            <a:schemeClr val="accent1"/>
-          </a:effectRef>
-          <a:fontRef idx="minor">
-            <a:schemeClr val="lt1"/>
-          </a:fontRef>
-        </p:style>
-        <p:txBody>
-          <a:bodyPr rtlCol="0" anchor="ctr"/>
-          <a:lstStyle/>
-          <a:p>
-            <a:pPr algn="ctr"/>
-          </a:p>
-        </p:txBody>
-      </p:sp>
-      <p:sp>
-        <p:nvSpPr>
           <p:cNvPr id="3" name="TextBox 2"/>
           <p:cNvSpPr txBox="1"/>
           <p:nvPr/>
@@ -4506,49 +4334,6 @@
       <p:grpSpPr/>
       <p:sp>
         <p:nvSpPr>
-          <p:cNvPr id="2" name="Rectangle 1"/>
-          <p:cNvSpPr/>
-          <p:nvPr/>
-        </p:nvSpPr>
-        <p:spPr>
-          <a:xfrm>
-            <a:off x="0" y="0"/>
-            <a:ext cx="82296" cy="6858000"/>
-          </a:xfrm>
-          <a:prstGeom prst="rect">
-            <a:avLst/>
-          </a:prstGeom>
-          <a:solidFill>
-            <a:srgbClr val="2A78D6"/>
-          </a:solidFill>
-          <a:ln>
-            <a:noFill/>
-          </a:ln>
-        </p:spPr>
-        <p:style>
-          <a:lnRef idx="1">
-            <a:schemeClr val="accent1"/>
-          </a:lnRef>
-          <a:fillRef idx="3">
-            <a:schemeClr val="accent1"/>
-          </a:fillRef>
-          <a:effectRef idx="2">
-            <a:schemeClr val="accent1"/>
-          </a:effectRef>
-          <a:fontRef idx="minor">
-            <a:schemeClr val="lt1"/>
-          </a:fontRef>
-        </p:style>
-        <p:txBody>
-          <a:bodyPr rtlCol="0" anchor="ctr"/>
-          <a:lstStyle/>
-          <a:p>
-            <a:pPr algn="ctr"/>
-          </a:p>
-        </p:txBody>
-      </p:sp>
-      <p:sp>
-        <p:nvSpPr>
           <p:cNvPr id="3" name="TextBox 2"/>
           <p:cNvSpPr txBox="1"/>
           <p:nvPr/>
@@ -5249,49 +5034,6 @@
       <p:grpSpPr/>
       <p:sp>
         <p:nvSpPr>
-          <p:cNvPr id="2" name="Rectangle 1"/>
-          <p:cNvSpPr/>
-          <p:nvPr/>
-        </p:nvSpPr>
-        <p:spPr>
-          <a:xfrm>
-            <a:off x="0" y="0"/>
-            <a:ext cx="82296" cy="6858000"/>
-          </a:xfrm>
-          <a:prstGeom prst="rect">
-            <a:avLst/>
-          </a:prstGeom>
-          <a:solidFill>
-            <a:srgbClr val="2A78D6"/>
-          </a:solidFill>
-          <a:ln>
-            <a:noFill/>
-          </a:ln>
-        </p:spPr>
-        <p:style>
-          <a:lnRef idx="1">
-            <a:schemeClr val="accent1"/>
-          </a:lnRef>
-          <a:fillRef idx="3">
-            <a:schemeClr val="accent1"/>
-          </a:fillRef>
-          <a:effectRef idx="2">
-            <a:schemeClr val="accent1"/>
-          </a:effectRef>
-          <a:fontRef idx="minor">
-            <a:schemeClr val="lt1"/>
-          </a:fontRef>
-        </p:style>
-        <p:txBody>
-          <a:bodyPr rtlCol="0" anchor="ctr"/>
-          <a:lstStyle/>
-          <a:p>
-            <a:pPr algn="ctr"/>
-          </a:p>
-        </p:txBody>
-      </p:sp>
-      <p:sp>
-        <p:nvSpPr>
           <p:cNvPr id="3" name="TextBox 2"/>
           <p:cNvSpPr txBox="1"/>
           <p:nvPr/>
@@ -5956,49 +5698,6 @@
       <p:grpSpPr/>
       <p:sp>
         <p:nvSpPr>
-          <p:cNvPr id="2" name="Rectangle 1"/>
-          <p:cNvSpPr/>
-          <p:nvPr/>
-        </p:nvSpPr>
-        <p:spPr>
-          <a:xfrm>
-            <a:off x="0" y="0"/>
-            <a:ext cx="82296" cy="6858000"/>
-          </a:xfrm>
-          <a:prstGeom prst="rect">
-            <a:avLst/>
-          </a:prstGeom>
-          <a:solidFill>
-            <a:srgbClr val="2A78D6"/>
-          </a:solidFill>
-          <a:ln>
-            <a:noFill/>
-          </a:ln>
-        </p:spPr>
-        <p:style>
-          <a:lnRef idx="1">
-            <a:schemeClr val="accent1"/>
-          </a:lnRef>
-          <a:fillRef idx="3">
-            <a:schemeClr val="accent1"/>
-          </a:fillRef>
-          <a:effectRef idx="2">
-            <a:schemeClr val="accent1"/>
-          </a:effectRef>
-          <a:fontRef idx="minor">
-            <a:schemeClr val="lt1"/>
-          </a:fontRef>
-        </p:style>
-        <p:txBody>
-          <a:bodyPr rtlCol="0" anchor="ctr"/>
-          <a:lstStyle/>
-          <a:p>
-            <a:pPr algn="ctr"/>
-          </a:p>
-        </p:txBody>
-      </p:sp>
-      <p:sp>
-        <p:nvSpPr>
           <p:cNvPr id="3" name="TextBox 2"/>
           <p:cNvSpPr txBox="1"/>
           <p:nvPr/>
@@ -6524,49 +6223,6 @@
       <p:grpSpPr/>
       <p:sp>
         <p:nvSpPr>
-          <p:cNvPr id="2" name="Rectangle 1"/>
-          <p:cNvSpPr/>
-          <p:nvPr/>
-        </p:nvSpPr>
-        <p:spPr>
-          <a:xfrm>
-            <a:off x="0" y="0"/>
-            <a:ext cx="82296" cy="6858000"/>
-          </a:xfrm>
-          <a:prstGeom prst="rect">
-            <a:avLst/>
-          </a:prstGeom>
-          <a:solidFill>
-            <a:srgbClr val="2A78D6"/>
-          </a:solidFill>
-          <a:ln>
-            <a:noFill/>
-          </a:ln>
-        </p:spPr>
-        <p:style>
-          <a:lnRef idx="1">
-            <a:schemeClr val="accent1"/>
-          </a:lnRef>
-          <a:fillRef idx="3">
-            <a:schemeClr val="accent1"/>
-          </a:fillRef>
-          <a:effectRef idx="2">
-            <a:schemeClr val="accent1"/>
-          </a:effectRef>
-          <a:fontRef idx="minor">
-            <a:schemeClr val="lt1"/>
-          </a:fontRef>
-        </p:style>
-        <p:txBody>
-          <a:bodyPr rtlCol="0" anchor="ctr"/>
-          <a:lstStyle/>
-          <a:p>
-            <a:pPr algn="ctr"/>
-          </a:p>
-        </p:txBody>
-      </p:sp>
-      <p:sp>
-        <p:nvSpPr>
           <p:cNvPr id="3" name="TextBox 2"/>
           <p:cNvSpPr txBox="1"/>
           <p:nvPr/>
@@ -7420,49 +7076,6 @@
       <p:grpSpPr/>
       <p:sp>
         <p:nvSpPr>
-          <p:cNvPr id="2" name="Rectangle 1"/>
-          <p:cNvSpPr/>
-          <p:nvPr/>
-        </p:nvSpPr>
-        <p:spPr>
-          <a:xfrm>
-            <a:off x="0" y="0"/>
-            <a:ext cx="82296" cy="6858000"/>
-          </a:xfrm>
-          <a:prstGeom prst="rect">
-            <a:avLst/>
-          </a:prstGeom>
-          <a:solidFill>
-            <a:srgbClr val="2A78D6"/>
-          </a:solidFill>
-          <a:ln>
-            <a:noFill/>
-          </a:ln>
-        </p:spPr>
-        <p:style>
-          <a:lnRef idx="1">
-            <a:schemeClr val="accent1"/>
-          </a:lnRef>
-          <a:fillRef idx="3">
-            <a:schemeClr val="accent1"/>
-          </a:fillRef>
-          <a:effectRef idx="2">
-            <a:schemeClr val="accent1"/>
-          </a:effectRef>
-          <a:fontRef idx="minor">
-            <a:schemeClr val="lt1"/>
-          </a:fontRef>
-        </p:style>
-        <p:txBody>
-          <a:bodyPr rtlCol="0" anchor="ctr"/>
-          <a:lstStyle/>
-          <a:p>
-            <a:pPr algn="ctr"/>
-          </a:p>
-        </p:txBody>
-      </p:sp>
-      <p:sp>
-        <p:nvSpPr>
           <p:cNvPr id="3" name="TextBox 2"/>
           <p:cNvSpPr txBox="1"/>
           <p:nvPr/>
@@ -8111,49 +7724,6 @@
       <p:grpSpPr/>
       <p:sp>
         <p:nvSpPr>
-          <p:cNvPr id="2" name="Rectangle 1"/>
-          <p:cNvSpPr/>
-          <p:nvPr/>
-        </p:nvSpPr>
-        <p:spPr>
-          <a:xfrm>
-            <a:off x="0" y="0"/>
-            <a:ext cx="82296" cy="6858000"/>
-          </a:xfrm>
-          <a:prstGeom prst="rect">
-            <a:avLst/>
-          </a:prstGeom>
-          <a:solidFill>
-            <a:srgbClr val="2A78D6"/>
-          </a:solidFill>
-          <a:ln>
-            <a:noFill/>
-          </a:ln>
-        </p:spPr>
-        <p:style>
-          <a:lnRef idx="1">
-            <a:schemeClr val="accent1"/>
-          </a:lnRef>
-          <a:fillRef idx="3">
-            <a:schemeClr val="accent1"/>
-          </a:fillRef>
-          <a:effectRef idx="2">
-            <a:schemeClr val="accent1"/>
-          </a:effectRef>
-          <a:fontRef idx="minor">
-            <a:schemeClr val="lt1"/>
-          </a:fontRef>
-        </p:style>
-        <p:txBody>
-          <a:bodyPr rtlCol="0" anchor="ctr"/>
-          <a:lstStyle/>
-          <a:p>
-            <a:pPr algn="ctr"/>
-          </a:p>
-        </p:txBody>
-      </p:sp>
-      <p:sp>
-        <p:nvSpPr>
           <p:cNvPr id="3" name="TextBox 2"/>
           <p:cNvSpPr txBox="1"/>
           <p:nvPr/>
@@ -8317,7 +7887,7 @@
         <p:spPr>
           <a:xfrm>
             <a:off x="685800" y="1737360"/>
-            <a:ext cx="10881360" cy="1417320"/>
+            <a:ext cx="7955279" cy="1417320"/>
           </a:xfrm>
           <a:prstGeom prst="rect">
             <a:avLst/>
@@ -8896,6 +8466,30 @@
           </a:p>
         </p:txBody>
       </p:sp>
+      <p:pic>
+        <p:nvPicPr>
+          <p:cNvPr id="18" name="Picture 17" descr="fig_launder_geo.png"/>
+          <p:cNvPicPr>
+            <a:picLocks noChangeAspect="1"/>
+          </p:cNvPicPr>
+          <p:nvPr/>
+        </p:nvPicPr>
+        <p:blipFill>
+          <a:blip r:embed="rId2"/>
+          <a:stretch>
+            <a:fillRect/>
+          </a:stretch>
+        </p:blipFill>
+        <p:spPr>
+          <a:xfrm>
+            <a:off x="9006840" y="1691640"/>
+            <a:ext cx="2331720" cy="1746504"/>
+          </a:xfrm>
+          <a:prstGeom prst="rect">
+            <a:avLst/>
+          </a:prstGeom>
+        </p:spPr>
+      </p:pic>
     </p:spTree>
   </p:cSld>
   <p:clrMapOvr>
@@ -8922,49 +8516,6 @@
         <p:nvPr/>
       </p:nvGrpSpPr>
       <p:grpSpPr/>
-      <p:sp>
-        <p:nvSpPr>
-          <p:cNvPr id="2" name="Rectangle 1"/>
-          <p:cNvSpPr/>
-          <p:nvPr/>
-        </p:nvSpPr>
-        <p:spPr>
-          <a:xfrm>
-            <a:off x="0" y="0"/>
-            <a:ext cx="82296" cy="6858000"/>
-          </a:xfrm>
-          <a:prstGeom prst="rect">
-            <a:avLst/>
-          </a:prstGeom>
-          <a:solidFill>
-            <a:srgbClr val="2A78D6"/>
-          </a:solidFill>
-          <a:ln>
-            <a:noFill/>
-          </a:ln>
-        </p:spPr>
-        <p:style>
-          <a:lnRef idx="1">
-            <a:schemeClr val="accent1"/>
-          </a:lnRef>
-          <a:fillRef idx="3">
-            <a:schemeClr val="accent1"/>
-          </a:fillRef>
-          <a:effectRef idx="2">
-            <a:schemeClr val="accent1"/>
-          </a:effectRef>
-          <a:fontRef idx="minor">
-            <a:schemeClr val="lt1"/>
-          </a:fontRef>
-        </p:style>
-        <p:txBody>
-          <a:bodyPr rtlCol="0" anchor="ctr"/>
-          <a:lstStyle/>
-          <a:p>
-            <a:pPr algn="ctr"/>
-          </a:p>
-        </p:txBody>
-      </p:sp>
       <p:sp>
         <p:nvSpPr>
           <p:cNvPr id="3" name="TextBox 2"/>
@@ -9623,49 +9174,6 @@
       <p:grpSpPr/>
       <p:sp>
         <p:nvSpPr>
-          <p:cNvPr id="2" name="Rectangle 1"/>
-          <p:cNvSpPr/>
-          <p:nvPr/>
-        </p:nvSpPr>
-        <p:spPr>
-          <a:xfrm>
-            <a:off x="0" y="0"/>
-            <a:ext cx="82296" cy="6858000"/>
-          </a:xfrm>
-          <a:prstGeom prst="rect">
-            <a:avLst/>
-          </a:prstGeom>
-          <a:solidFill>
-            <a:srgbClr val="2A78D6"/>
-          </a:solidFill>
-          <a:ln>
-            <a:noFill/>
-          </a:ln>
-        </p:spPr>
-        <p:style>
-          <a:lnRef idx="1">
-            <a:schemeClr val="accent1"/>
-          </a:lnRef>
-          <a:fillRef idx="3">
-            <a:schemeClr val="accent1"/>
-          </a:fillRef>
-          <a:effectRef idx="2">
-            <a:schemeClr val="accent1"/>
-          </a:effectRef>
-          <a:fontRef idx="minor">
-            <a:schemeClr val="lt1"/>
-          </a:fontRef>
-        </p:style>
-        <p:txBody>
-          <a:bodyPr rtlCol="0" anchor="ctr"/>
-          <a:lstStyle/>
-          <a:p>
-            <a:pPr algn="ctr"/>
-          </a:p>
-        </p:txBody>
-      </p:sp>
-      <p:sp>
-        <p:nvSpPr>
           <p:cNvPr id="3" name="TextBox 2"/>
           <p:cNvSpPr txBox="1"/>
           <p:nvPr/>

</xml_diff>

<commit_message>
@ Slide 7: shorten CB-SAFE+ bullets so they clear the step row
Narrowing the text column for the laundering illustration made the bullets wrap
taller and overlap the 5-step process row; tighten both bullets to fit.

Co-Authored-By: Claude Opus 4.8 <noreply@anthropic.com>
@
</commit_message>
<xml_diff>
--- a/paper/cbsafe_slides.pptx
+++ b/paper/cbsafe_slides.pptx
@@ -7915,25 +7915,7 @@
                 </a:solidFill>
                 <a:latin typeface="Segoe UI"/>
               </a:rPr>
-              <a:t>▪  </a:t>
-            </a:r>
-            <a:r>
-              <a:rPr sz="1600" b="1">
-                <a:solidFill>
-                  <a:srgbClr val="0B0B0B"/>
-                </a:solidFill>
-                <a:latin typeface="Segoe UI"/>
-              </a:rPr>
-              <a:t>Key insight: </a:t>
-            </a:r>
-            <a:r>
-              <a:rPr sz="1600">
-                <a:solidFill>
-                  <a:srgbClr val="26251F"/>
-                </a:solidFill>
-                <a:latin typeface="Segoe UI"/>
-              </a:rPr>
-              <a:t>a poisoned cluster sum looks normal in size but pushes the model the wrong way; a tiny server-side dataset (200 samples) exposes it: applying that sum raises the loss.</a:t>
+              <a:t>▪  Key insight: a poisoned cluster sum is normal in size but points the wrong way; a 200-sample server set exposes it (loss goes up).</a:t>
             </a:r>
           </a:p>
           <a:p>
@@ -7952,25 +7934,7 @@
                 </a:solidFill>
                 <a:latin typeface="Segoe UI"/>
               </a:rPr>
-              <a:t>▪  </a:t>
-            </a:r>
-            <a:r>
-              <a:rPr sz="1600" b="1">
-                <a:solidFill>
-                  <a:srgbClr val="0B0B0B"/>
-                </a:solidFill>
-                <a:latin typeface="Segoe UI"/>
-              </a:rPr>
-              <a:t>Repetition identifies individuals: </a:t>
-            </a:r>
-            <a:r>
-              <a:rPr sz="1600">
-                <a:solidFill>
-                  <a:srgbClr val="26251F"/>
-                </a:solidFill>
-                <a:latin typeface="Segoe UI"/>
-              </a:rPr>
-              <a:t>clusters are reshuffled every round, so a real attacker is inside a flagged cluster almost every round while honest clients are flagged only occasionally.</a:t>
+              <a:t>▪  Repetition finds individuals: clusters reshuffle each round, so a true attacker sits in a flagged cluster almost always, honest clients only rarely.</a:t>
             </a:r>
           </a:p>
         </p:txBody>

</xml_diff>

<commit_message>
@ Slides: add masking cartoon (slide 6) + non-IID heatmap (slide 8)
Slide 6: compact +m/-m cancellation cartoon top-right, bullets shortened to clear
the flow boxes. Slide 8: narrow the KPI table and add the Dirichlet non-IID
heatmap with a caption on the right. Preserves the (bar-free) DNA.

Co-Authored-By: Claude Opus 4.8 <noreply@anthropic.com>
@
</commit_message>
<xml_diff>
--- a/paper/cbsafe_slides.pptx
+++ b/paper/cbsafe_slides.pptx
@@ -7239,7 +7239,7 @@
         <p:spPr>
           <a:xfrm>
             <a:off x="685800" y="1737360"/>
-            <a:ext cx="10881360" cy="1737360"/>
+            <a:ext cx="6766560" cy="1737360"/>
           </a:xfrm>
           <a:prstGeom prst="rect">
             <a:avLst/>
@@ -7267,25 +7267,7 @@
                 </a:solidFill>
                 <a:latin typeface="Segoe UI"/>
               </a:rPr>
-              <a:t>▪  </a:t>
-            </a:r>
-            <a:r>
-              <a:rPr sz="1600" b="1">
-                <a:solidFill>
-                  <a:srgbClr val="0B0B0B"/>
-                </a:solidFill>
-                <a:latin typeface="Segoe UI"/>
-              </a:rPr>
-              <a:t>Each client adds secret masks to its update; </a:t>
-            </a:r>
-            <a:r>
-              <a:rPr sz="1600">
-                <a:solidFill>
-                  <a:srgbClr val="26251F"/>
-                </a:solidFill>
-                <a:latin typeface="Segoe UI"/>
-              </a:rPr>
-              <a:t>within a cluster the masks cancel, so the sum is exact but individuals stay hidden (anonymity set = cluster size).</a:t>
+              <a:t>▪  Masks cancel within a cluster: the sum is exact, individuals stay hidden (anonymity set = cluster size).</a:t>
             </a:r>
           </a:p>
           <a:p>
@@ -7304,25 +7286,7 @@
                 </a:solidFill>
                 <a:latin typeface="Segoe UI"/>
               </a:rPr>
-              <a:t>▪  </a:t>
-            </a:r>
-            <a:r>
-              <a:rPr sz="1600" b="1">
-                <a:solidFill>
-                  <a:srgbClr val="0B0B0B"/>
-                </a:solidFill>
-                <a:latin typeface="Segoe UI"/>
-              </a:rPr>
-              <a:t>Guarantee (proved): </a:t>
-            </a:r>
-            <a:r>
-              <a:rPr sz="1600">
-                <a:solidFill>
-                  <a:srgbClr val="26251F"/>
-                </a:solidFill>
-                <a:latin typeface="Segoe UI"/>
-              </a:rPr>
-              <a:t>the server, even colluding with some clients, learns nothing beyond each cluster's sum.</a:t>
+              <a:t>▪  Proved: the server, even colluding with some clients, learns nothing beyond each cluster sum.</a:t>
             </a:r>
           </a:p>
           <a:p>
@@ -7341,25 +7305,7 @@
                 </a:solidFill>
                 <a:latin typeface="Segoe UI"/>
               </a:rPr>
-              <a:t>▪  </a:t>
-            </a:r>
-            <a:r>
-              <a:rPr sz="1600" b="1">
-                <a:solidFill>
-                  <a:srgbClr val="0B0B0B"/>
-                </a:solidFill>
-                <a:latin typeface="Segoe UI"/>
-              </a:rPr>
-              <a:t>Dropouts handled: </a:t>
-            </a:r>
-            <a:r>
-              <a:rPr sz="1600">
-                <a:solidFill>
-                  <a:srgbClr val="26251F"/>
-                </a:solidFill>
-                <a:latin typeface="Segoe UI"/>
-              </a:rPr>
-              <a:t>secret-sharing recovers the masks of clients who disconnect mid-round.</a:t>
+              <a:t>▪  Dropouts: secret-sharing recovers the masks of clients who leave mid-round.</a:t>
             </a:r>
           </a:p>
         </p:txBody>
@@ -7696,6 +7642,30 @@
           </a:p>
         </p:txBody>
       </p:sp>
+      <p:pic>
+        <p:nvPicPr>
+          <p:cNvPr id="15" name="Picture 14" descr="fig_masking.png"/>
+          <p:cNvPicPr>
+            <a:picLocks noChangeAspect="1"/>
+          </p:cNvPicPr>
+          <p:nvPr/>
+        </p:nvPicPr>
+        <p:blipFill>
+          <a:blip r:embed="rId2"/>
+          <a:stretch>
+            <a:fillRect/>
+          </a:stretch>
+        </p:blipFill>
+        <p:spPr>
+          <a:xfrm>
+            <a:off x="8732520" y="1783080"/>
+            <a:ext cx="2697480" cy="1929384"/>
+          </a:xfrm>
+          <a:prstGeom prst="rect">
+            <a:avLst/>
+          </a:prstGeom>
+        </p:spPr>
+      </p:pic>
     </p:spTree>
   </p:cSld>
   <p:clrMapOvr>
@@ -8646,7 +8616,7 @@
         </p:nvGraphicFramePr>
         <p:xfrm>
           <a:off x="685800" y="1783080"/>
-          <a:ext cx="10835640" cy="3566160"/>
+          <a:ext cx="6858000" cy="3566160"/>
         </p:xfrm>
         <a:graphic>
           <a:graphicData uri="http://schemas.openxmlformats.org/drawingml/2006/table">
@@ -8655,9 +8625,9 @@
                 <a:tableStyleId>{5C22544A-7EE6-4342-B048-85BDC9FD1C3A}</a:tableStyleId>
               </a:tblPr>
               <a:tblGrid>
-                <a:gridCol w="2743200"/>
-                <a:gridCol w="4160520"/>
-                <a:gridCol w="3931920"/>
+                <a:gridCol w="1736202"/>
+                <a:gridCol w="2633240"/>
+                <a:gridCol w="2488556"/>
               </a:tblGrid>
               <a:tr h="594360">
                 <a:tc>
@@ -9110,6 +9080,64 @@
           </a:p>
         </p:txBody>
       </p:sp>
+      <p:pic>
+        <p:nvPicPr>
+          <p:cNvPr id="9" name="Picture 8" descr="fig_dirichlet_slide.png"/>
+          <p:cNvPicPr>
+            <a:picLocks noChangeAspect="1"/>
+          </p:cNvPicPr>
+          <p:nvPr/>
+        </p:nvPicPr>
+        <p:blipFill>
+          <a:blip r:embed="rId2"/>
+          <a:stretch>
+            <a:fillRect/>
+          </a:stretch>
+        </p:blipFill>
+        <p:spPr>
+          <a:xfrm>
+            <a:off x="7772400" y="1965960"/>
+            <a:ext cx="3794760" cy="2514600"/>
+          </a:xfrm>
+          <a:prstGeom prst="rect">
+            <a:avLst/>
+          </a:prstGeom>
+        </p:spPr>
+      </p:pic>
+      <p:sp>
+        <p:nvSpPr>
+          <p:cNvPr id="10" name="TextBox 9"/>
+          <p:cNvSpPr txBox="1"/>
+          <p:nvPr/>
+        </p:nvSpPr>
+        <p:spPr>
+          <a:xfrm>
+            <a:off x="7772400" y="4526280"/>
+            <a:ext cx="3794760" cy="457200"/>
+          </a:xfrm>
+          <a:prstGeom prst="rect">
+            <a:avLst/>
+          </a:prstGeom>
+          <a:noFill/>
+        </p:spPr>
+        <p:txBody>
+          <a:bodyPr wrap="none">
+            <a:spAutoFit/>
+          </a:bodyPr>
+          <a:lstStyle/>
+          <a:p>
+            <a:r>
+              <a:rPr sz="684" i="1">
+                <a:solidFill>
+                  <a:srgbClr val="898781"/>
+                </a:solidFill>
+                <a:latin typeface="Segoe UI"/>
+              </a:rPr>
+              <a:t>Non-IID split (Dirichlet a=0.5): highly uneven per-client class counts.</a:t>
+            </a:r>
+          </a:p>
+        </p:txBody>
+      </p:sp>
     </p:spTree>
   </p:cSld>
   <p:clrMapOvr>

</xml_diff>

<commit_message>
@ Refresh both decks to reuse current paper figures
Full research deck (cbsafe_slides): robustness slide -> FashionMNIST sign-flip,
generalization slide -> training-dynamics figure, with captions/bullets updated to
match (FMNIST ~85%, round-by-round). Method deck (cbsafe_method_slides): rebuilt so
its comparison slide uses the FMNIST sign-flip figure. Regenerate slide-res PNGs
from the current paper PDFs.

Co-Authored-By: Claude Opus 4.8 <noreply@anthropic.com>
@
</commit_message>
<xml_diff>
--- a/paper/cbsafe_slides.pptx
+++ b/paper/cbsafe_slides.pptx
@@ -5812,7 +5812,7 @@
                 </a:solidFill>
                 <a:latin typeface="Segoe UI"/>
               </a:rPr>
-              <a:t>▪  Ties the state of the art: at f = 30% CB-SAFE+ holds ~50% accuracy, matching FedGT (TIFS 2025), while catching 3/3, 6/6, 9/9 attackers with far fewer false exclusions (0.0 / 0.7 / 0.3 vs FedGT 1.3 / 3.3 / 1.3).</a:t>
+              <a:t>▪  Ties the state of the art: at f = 30% CB-SAFE+ holds ~85% accuracy (FashionMNIST), matching FedGT (TIFS 2025), while catching 3/3, 6/6, 9/9 attackers with far fewer false exclusions (0.0 / 0.7 / 0.3 vs FedGT 1.3 / 3.3 / 1.3).</a:t>
             </a:r>
           </a:p>
           <a:p>
@@ -5870,7 +5870,7 @@
                 </a:solidFill>
                 <a:latin typeface="Segoe UI"/>
               </a:rPr>
-              <a:t>Sign-flip attack on CIFAR-10: accuracy vs attacker fraction across eight rules; only CB-SAFE+ and FedGT stay near the clean baseline.</a:t>
+              <a:t>Sign-flip attack on FashionMNIST: accuracy vs attacker fraction across eight rules; only CB-SAFE+ and FedGT stay near the clean baseline.</a:t>
             </a:r>
           </a:p>
         </p:txBody>
@@ -5884,7 +5884,7 @@
           <p:nvPr/>
         </p:nvPicPr>
         <p:blipFill>
-          <a:blip r:embed="rId3"/>
+          <a:blip r:embed="rId4"/>
           <a:stretch>
             <a:fillRect/>
           </a:stretch>
@@ -5980,7 +5980,7 @@
                 </a:solidFill>
                 <a:latin typeface="Segoe UI"/>
               </a:rPr>
-              <a:t>Same story across domains; the privacy dial</a:t>
+              <a:t>Same story across domains, round by round</a:t>
             </a:r>
           </a:p>
         </p:txBody>
@@ -6143,14 +6143,14 @@
       </p:sp>
       <p:pic>
         <p:nvPicPr>
-          <p:cNvPr id="7" name="Picture 6" descr="fig_gen_slide.png"/>
+          <p:cNvPr id="7" name="Picture 6" descr="fig_dynamics_signflip_slide.png"/>
           <p:cNvPicPr>
             <a:picLocks noChangeAspect="1"/>
           </p:cNvPicPr>
           <p:nvPr/>
         </p:nvPicPr>
         <p:blipFill>
-          <a:blip r:embed="rId2"/>
+          <a:blip r:embed="rId3"/>
           <a:stretch>
             <a:fillRect/>
           </a:stretch>

</xml_diff>